<commit_message>
Add registration number, supervisor and faculty to the soursop deck title slide
Co-Authored-By: Claude Opus 5.5 <noreply@anthropic.com>
Claude-Session: https://claude.ai/code/session_01LRgAywWUpAqV5tRHALsb91
</commit_message>
<xml_diff>
--- a/thesis-presentations/Soursop_Ultrasound_Vacuum_Drying.pptx
+++ b/thesis-presentations/Soursop_Ultrasound_Vacuum_Drying.pptx
@@ -3539,8 +3539,8 @@
         </p:nvSpPr>
         <p:spPr>
           <a:xfrm>
-            <a:off x="457200" y="3108960"/>
-            <a:ext cx="4389120" cy="731520"/>
+            <a:off x="457200" y="2926080"/>
+            <a:ext cx="4389120" cy="640080"/>
           </a:xfrm>
           <a:prstGeom prst="rect">
             <a:avLst/>
@@ -3549,80 +3549,97 @@
           <a:ln/>
         </p:spPr>
         <p:txBody>
-          <a:bodyPr wrap="square" lIns="0" tIns="0" rIns="0" bIns="0" rtlCol="0" anchor="ctr"/>
+          <a:bodyPr wrap="square" lIns="0" tIns="0" rIns="0" bIns="0" rtlCol="0" anchor="t"/>
           <a:lstStyle/>
           <a:p>
             <a:pPr indent="0" marL="0">
               <a:buNone/>
             </a:pPr>
             <a:r>
-              <a:rPr lang="en-US" sz="1300" i="1" dirty="0">
-                <a:solidFill>
-                  <a:srgbClr val="CFE3D4"/>
+              <a:rPr lang="en-US" sz="1400" b="1" dirty="0">
+                <a:solidFill>
+                  <a:srgbClr val="FFFFFF"/>
                 </a:solidFill>
                 <a:latin typeface="Calibri" pitchFamily="34" charset="0"/>
                 <a:ea typeface="Calibri" pitchFamily="34" charset="-122"/>
                 <a:cs typeface="Calibri" pitchFamily="34" charset="-120"/>
               </a:rPr>
-              <a:t>Drying kinetics, thin-layer modelling, effective moisture diffusivity and activation energy under a 4 × 3 factorial design</a:t>
-            </a:r>
-            <a:endParaRPr lang="en-US" sz="1300" dirty="0"/>
-          </a:p>
-        </p:txBody>
-      </p:sp>
-      <p:sp>
-        <p:nvSpPr>
-          <p:cNvPr id="6" name="Text 3"/>
-          <p:cNvSpPr txBox="1"/>
-          <p:nvPr/>
-        </p:nvSpPr>
-        <p:spPr>
-          <a:xfrm>
-            <a:off x="457200" y="4069080"/>
-            <a:ext cx="4389120" cy="548640"/>
-          </a:xfrm>
-          <a:prstGeom prst="rect">
-            <a:avLst/>
-          </a:prstGeom>
-          <a:noFill/>
-          <a:ln/>
-        </p:spPr>
-        <p:txBody>
-          <a:bodyPr wrap="square" lIns="0" tIns="0" rIns="0" bIns="0" rtlCol="0" anchor="ctr"/>
-          <a:lstStyle/>
+              <a:t>Reg. No.: 20/EG/FE/580</a:t>
+            </a:r>
+            <a:endParaRPr lang="en-US" sz="1400" dirty="0"/>
+          </a:p>
           <a:p>
             <a:pPr indent="0" marL="0">
               <a:buNone/>
             </a:pPr>
             <a:r>
-              <a:rPr lang="en-US" sz="1200" dirty="0">
-                <a:solidFill>
-                  <a:srgbClr val="FFFFFF"/>
+              <a:rPr lang="en-US" sz="1250" dirty="0">
+                <a:solidFill>
+                  <a:srgbClr val="CFE3D4"/>
                 </a:solidFill>
                 <a:latin typeface="Calibri" pitchFamily="34" charset="0"/>
                 <a:ea typeface="Calibri" pitchFamily="34" charset="-122"/>
                 <a:cs typeface="Calibri" pitchFamily="34" charset="-120"/>
               </a:rPr>
-              <a:t>Department of Agricultural and Food Engineering</a:t>
-            </a:r>
-            <a:endParaRPr lang="en-US" sz="1200" dirty="0"/>
-          </a:p>
+              <a:t>Supervisor: Dr. Ayobami Olayemi Oladejo</a:t>
+            </a:r>
+            <a:endParaRPr lang="en-US" sz="1400" dirty="0"/>
+          </a:p>
+        </p:txBody>
+      </p:sp>
+      <p:sp>
+        <p:nvSpPr>
+          <p:cNvPr id="6" name="Text 3"/>
+          <p:cNvSpPr txBox="1"/>
+          <p:nvPr/>
+        </p:nvSpPr>
+        <p:spPr>
+          <a:xfrm>
+            <a:off x="457200" y="4114800"/>
+            <a:ext cx="4389120" cy="548640"/>
+          </a:xfrm>
+          <a:prstGeom prst="rect">
+            <a:avLst/>
+          </a:prstGeom>
+          <a:noFill/>
+          <a:ln/>
+        </p:spPr>
+        <p:txBody>
+          <a:bodyPr wrap="square" lIns="0" tIns="0" rIns="0" bIns="0" rtlCol="0" anchor="ctr"/>
+          <a:lstStyle/>
           <a:p>
             <a:pPr indent="0" marL="0">
               <a:buNone/>
             </a:pPr>
             <a:r>
-              <a:rPr lang="en-US" sz="1200" dirty="0">
-                <a:solidFill>
-                  <a:srgbClr val="FFFFFF"/>
+              <a:rPr lang="en-US" sz="1150" dirty="0">
+                <a:solidFill>
+                  <a:srgbClr val="CFE3D4"/>
                 </a:solidFill>
                 <a:latin typeface="Calibri" pitchFamily="34" charset="0"/>
                 <a:ea typeface="Calibri" pitchFamily="34" charset="-122"/>
                 <a:cs typeface="Calibri" pitchFamily="34" charset="-120"/>
               </a:rPr>
-              <a:t>University of Uyo</a:t>
-            </a:r>
-            <a:endParaRPr lang="en-US" sz="1200" dirty="0"/>
+              <a:t>Department of Agricultural and Food Engineering</a:t>
+            </a:r>
+            <a:endParaRPr lang="en-US" sz="1150" dirty="0"/>
+          </a:p>
+          <a:p>
+            <a:pPr indent="0" marL="0">
+              <a:buNone/>
+            </a:pPr>
+            <a:r>
+              <a:rPr lang="en-US" sz="1150" dirty="0">
+                <a:solidFill>
+                  <a:srgbClr val="CFE3D4"/>
+                </a:solidFill>
+                <a:latin typeface="Calibri" pitchFamily="34" charset="0"/>
+                <a:ea typeface="Calibri" pitchFamily="34" charset="-122"/>
+                <a:cs typeface="Calibri" pitchFamily="34" charset="-120"/>
+              </a:rPr>
+              <a:t>Faculty of Engineering, University of Uyo</a:t>
+            </a:r>
+            <a:endParaRPr lang="en-US" sz="1150" dirty="0"/>
           </a:p>
         </p:txBody>
       </p:sp>

</xml_diff>

<commit_message>
Add Grace Bill Uro's name to the soursop deck title slide
Co-Authored-By: Claude Opus 5.5 <noreply@anthropic.com>
Claude-Session: https://claude.ai/code/session_01LRgAywWUpAqV5tRHALsb91
</commit_message>
<xml_diff>
--- a/thesis-presentations/Soursop_Ultrasound_Vacuum_Drying.pptx
+++ b/thesis-presentations/Soursop_Ultrasound_Vacuum_Drying.pptx
@@ -3539,8 +3539,8 @@
         </p:nvSpPr>
         <p:spPr>
           <a:xfrm>
-            <a:off x="457200" y="2926080"/>
-            <a:ext cx="4389120" cy="640080"/>
+            <a:off x="457200" y="2880360"/>
+            <a:ext cx="4389120" cy="868680"/>
           </a:xfrm>
           <a:prstGeom prst="rect">
             <a:avLst/>
@@ -3556,7 +3556,7 @@
               <a:buNone/>
             </a:pPr>
             <a:r>
-              <a:rPr lang="en-US" sz="1400" b="1" dirty="0">
+              <a:rPr lang="en-US" sz="1500" b="1" dirty="0">
                 <a:solidFill>
                   <a:srgbClr val="FFFFFF"/>
                 </a:solidFill>
@@ -3564,16 +3564,16 @@
                 <a:ea typeface="Calibri" pitchFamily="34" charset="-122"/>
                 <a:cs typeface="Calibri" pitchFamily="34" charset="-120"/>
               </a:rPr>
-              <a:t>Reg. No.: 20/EG/FE/580</a:t>
-            </a:r>
-            <a:endParaRPr lang="en-US" sz="1400" dirty="0"/>
+              <a:t>Grace Bill Uro</a:t>
+            </a:r>
+            <a:endParaRPr lang="en-US" sz="1500" dirty="0"/>
           </a:p>
           <a:p>
             <a:pPr indent="0" marL="0">
               <a:buNone/>
             </a:pPr>
             <a:r>
-              <a:rPr lang="en-US" sz="1250" dirty="0">
+              <a:rPr lang="en-US" sz="1200" dirty="0">
                 <a:solidFill>
                   <a:srgbClr val="CFE3D4"/>
                 </a:solidFill>
@@ -3581,9 +3581,26 @@
                 <a:ea typeface="Calibri" pitchFamily="34" charset="-122"/>
                 <a:cs typeface="Calibri" pitchFamily="34" charset="-120"/>
               </a:rPr>
+              <a:t>20/EG/FE/580</a:t>
+            </a:r>
+            <a:endParaRPr lang="en-US" sz="1500" dirty="0"/>
+          </a:p>
+          <a:p>
+            <a:pPr indent="0" marL="0">
+              <a:buNone/>
+            </a:pPr>
+            <a:r>
+              <a:rPr lang="en-US" sz="1200" dirty="0">
+                <a:solidFill>
+                  <a:srgbClr val="CFE3D4"/>
+                </a:solidFill>
+                <a:latin typeface="Calibri" pitchFamily="34" charset="0"/>
+                <a:ea typeface="Calibri" pitchFamily="34" charset="-122"/>
+                <a:cs typeface="Calibri" pitchFamily="34" charset="-120"/>
+              </a:rPr>
               <a:t>Supervisor: Dr. Ayobami Olayemi Oladejo</a:t>
             </a:r>
-            <a:endParaRPr lang="en-US" sz="1400" dirty="0"/>
+            <a:endParaRPr lang="en-US" sz="1500" dirty="0"/>
           </a:p>
         </p:txBody>
       </p:sp>

</xml_diff>